<commit_message>
Prepare ikom_osos for public release
- Add MIT LICENSE, CI for Python tests, license/third-party README note
- Untrack generated ESP-IDF managed_components and sdkconfig; ignore them
- Make .gitignore actually exclude config.h, broker.env, config.js, keystores
- Scrub SSID, MAC and EMQX deployment host from docs, code and decks
- Android: disable cleartext traffic and app backup (broker password in prefs)
- Fix presentation build paths to match repo layout

Co-Authored-By: Claude Sonnet 5.5 <noreply@anthropic.com>
Claude-Session: https://claude.ai/code/session_014y6XjDKaUtvDjB98eq7MsM
</commit_message>
<xml_diff>
--- a/presentation/OSOS-Delivery-long-cut.pptx
+++ b/presentation/OSOS-Delivery-long-cut.pptx
@@ -10954,7 +10954,7 @@
                 </a:solidFill>
                 <a:latin typeface="Consolas"/>
               </a:rPr>
-              <a:t>mqtt: connecting to nba17802...emqxsl.com:8883 ... ok</a:t>
+              <a:t>mqtt: connecting to your-deployment.emqxsl.com:8883 ... ok</a:t>
             </a:r>
           </a:p>
           <a:p>
@@ -29907,7 +29907,7 @@
                 </a:solidFill>
                 <a:latin typeface="Segoe UI"/>
               </a:rPr>
-              <a:t>  Its address is a DHCP reservation on MAC 00-00-36-7F-04-55, because CFG_METER_HOST is a compile-time constant.</a:t>
+              <a:t>  Its address is a DHCP reservation on MAC xx-xx-xx-xx-xx-xx, because CFG_METER_HOST is a compile-time constant.</a:t>
             </a:r>
           </a:p>
         </p:txBody>
@@ -58444,7 +58444,7 @@
                 </a:solidFill>
                 <a:latin typeface="Consolas"/>
               </a:rPr>
-              <a:t>SSID IKOM_Bilisim</a:t>
+              <a:t>SSID your-ssid</a:t>
             </a:r>
           </a:p>
         </p:txBody>
@@ -66546,7 +66546,7 @@
                 </a:solidFill>
                 <a:latin typeface="Consolas"/>
               </a:rPr>
-              <a:t>Ethernet II   MAC 00-00-36-7F-04-55</a:t>
+              <a:t>Ethernet II   MAC xx-xx-xx-xx-xx-xx</a:t>
             </a:r>
           </a:p>
         </p:txBody>
@@ -66588,7 +66588,7 @@
                 </a:solidFill>
                 <a:latin typeface="Consolas"/>
               </a:rPr>
-              <a:t>802.11 b/g/n   CSMA/CA, SSID IKOM_Bilisim</a:t>
+              <a:t>802.11 b/g/n   CSMA/CA, SSID your-ssid</a:t>
             </a:r>
           </a:p>
         </p:txBody>

</xml_diff>